<commit_message>
docs: explain task inputs and outputs using course terminology
</commit_message>
<xml_diff>
--- a/presentation/Презентация.pptx
+++ b/presentation/Презентация.pptx
@@ -1,6 +1,6 @@
 
 <file path=ppt/presentation.xml><?xml version="1.0" encoding="utf-8"?>
-<p:presentation xmlns:a="http://schemas.openxmlformats.org/drawingml/2006/main" xmlns:r="http://schemas.openxmlformats.org/officeDocument/2006/relationships" xmlns:p="http://schemas.openxmlformats.org/presentationml/2006/main" showSpecialPlsOnTitleSld="0" strictFirstAndLastChars="0" embedTrueTypeFonts="0" saveSubsetFonts="0" autoCompressPictures="0">
+<p:presentation xmlns:a="http://schemas.openxmlformats.org/drawingml/2006/main" xmlns:r="http://schemas.openxmlformats.org/officeDocument/2006/relationships" xmlns:p="http://schemas.openxmlformats.org/presentationml/2006/main" showSpecialPlsOnTitleSld="0" strictFirstAndLastChars="0" autoCompressPictures="0">
   <p:sldMasterIdLst>
     <p:sldMasterId id="2147483648" r:id="rId1"/>
   </p:sldMasterIdLst>
@@ -1287,9 +1287,10 @@
               <a:rPr lang="ru-RU">
                 <a:latin typeface="Arial" panose="020B0604020202020204" pitchFamily="34" charset="0"/>
               </a:rPr>
-              <a:t>Композит сочетает матрицу и наполнитель. Матрица – это связующее, которое удерживает компоненты. Наполнитель – второй компонент, например усиливающие волокна. В самой таблице конкретные типы материалов не указаны, поэтому я не приписываю их наблюдениям.
-В работе оцениваются две конечные характеристики. Модуль упругости при растяжении характеризует жёсткость: чем он выше, тем меньше материал удлиняется при том же напряжении в области обратимой деформации. После снятия нагрузки форма возвращается. Прочность при растяжении – предельное напряжение перед разрушением. Напряжение здесь означает нагрузку на единицу площади поперечного сечения.
-Источники: РПЗ, таблица 1.</a:t>
+              <a:t>Свойства готового материала зависят от сочетания компонентов и условий изготовления. Задача работы – прогнозировать эти свойства по имеющимся характеристикам.
+Связующее, или матрица, соединяет компоненты в единый материал и передаёт нагрузку. Наполнитель влияет на свойства материала и может выполнять армирующую функцию, то есть усиливать материал.
+В работе оцениваются две конечные характеристики. Модуль упругости при растяжении показывает сопротивление обратимому растяжению: после снятия нагрузки форма восстанавливается. Прочность при растяжении – предельное напряжение перед разрушением. Напряжение здесь означает нагрузку на единицу площади поперечного сечения.
+Источники: РПЗ, введение, с. 3.</a:t>
             </a:r>
             <a:endParaRPr>
               <a:latin typeface="Arial" panose="020B0604020202020204" pitchFamily="34" charset="0"/>
@@ -1358,8 +1359,8 @@
               <a:rPr lang="ru-RU">
                 <a:latin typeface="Arial" panose="020B0604020202020204" pitchFamily="34" charset="0"/>
               </a:rPr>
-              <a:t>Исходные данные находились в двух таблицах Excel. Применён INNER JOIN: после объединения оставлены только строки, которые присутствуют в обеих таблицах. Их сопоставили по исходному индексу по правилу «одна строка к одной». Получено 1023 наблюдения и 13 полей. Семнадцать строк второй таблицы не имели пары и не вошли в итоговый набор. Пропусков и полных дубликатов нет.
-При этом происхождение образцов, группы, партии и часть единиц измерения в материалах не описаны. Это ограничивает интерпретацию и возможность проверки переноса результата на новые материалы.
+              <a:t>Исходные данные находились в двух таблицах Excel, которые дополняют друг друга. Применён INNER JOIN: таблицы сопоставили по исходному индексу и оставили только строки, присутствующие в обеих таблицах. Получено 1023 наблюдения с 13 показателями; 17 строк второй таблицы без пары не вошли в итоговый набор. Пропусков и полных дубликатов нет.
+После объединения каждая строка содержит характеристики и известные конечные свойства. Такая строка служит примером, на котором можно обучать и проверять модель. Происхождение образцов, группы, партии и часть единиц измерения не описаны; это ограничение учитывается при интерпретации результатов.
 Источники: РПЗ, таблица 4; docs/data_dictionary.md.</a:t>
             </a:r>
             <a:endParaRPr>
@@ -1429,9 +1430,10 @@
               <a:rPr lang="ru-RU">
                 <a:latin typeface="Arial" panose="020B0604020202020204" pitchFamily="34" charset="0"/>
               </a:rPr>
-              <a:t>Для двух прямых задач использовались 11 входных параметров состава и технологии. Первая цель – модуль упругости при растяжении, вторая – прочность при растяжении. Обе конечные характеристики исключены из входов, поэтому модель не получает готовый ответ.
-Отдельная задача – восстановление соотношения матрица–наполнитель. Для неё используются 12 остальных полей, включая уже известные модуль и прочность. Это оценка наблюдаемого отношения по известному профилю. Она не оптимизирует рецептуру и не предлагает новый состав.
-Источники: РПЗ, таблица 1; docs/data_dictionary.md.</a:t>
+              <a:t>Для прямого прогнозирования используются 11 характеристик состава и технологии. Из 1023 строк 716 образуют обучающую выборку, а 307 – независимую тестовую выборку. На обучающей части модель учится связывать 11 входных характеристик с известными конечными свойствами, а тестовая часть показывает качество на данных, которые не использовались при обучении.
+Для нового набора из 11 характеристик модель выдаёт две оценки: модуль упругости при растяжении в гигапаскалях и прочность при растяжении в мегапаскалях. Сами конечные свойства в эти 11 входов не входят.
+Отдельно решается дополнительная задача: по 12 другим известным показателям, включая известные модуль и прочность, оценивается соотношение матрица–наполнитель. Эта задача отделена от двух прямых прогнозов и в приложение не включена.
+Источники: РПЗ, раздел 1.1, с. 4–5; docs/data_dictionary.md.</a:t>
             </a:r>
             <a:endParaRPr>
               <a:latin typeface="Arial" panose="020B0604020202020204" pitchFamily="34" charset="0"/>
@@ -14947,16 +14949,14 @@
                 <a:solidFill>
                   <a:srgbClr val="F1BE29"/>
                 </a:solidFill>
-                <a:latin typeface="Arial" panose="020B0604020202020204" pitchFamily="34" charset="0"/>
                 <a:cs typeface="Arial"/>
               </a:rPr>
-              <a:t>Композит сочетает матрицу и наполнитель</a:t>
+              <a:t>Свойства зависят от сочетания компонентов и условий изготовления</a:t>
             </a:r>
             <a:endParaRPr sz="2200" b="1" i="0">
               <a:solidFill>
                 <a:srgbClr val="F1BE29"/>
               </a:solidFill>
-              <a:latin typeface="Arial" panose="020B0604020202020204" pitchFamily="34" charset="0"/>
               <a:cs typeface="Arial"/>
             </a:endParaRPr>
           </a:p>
@@ -15040,7 +15040,7 @@
                   <a:latin typeface="Arial" panose="020B0604020202020204" pitchFamily="34" charset="0"/>
                   <a:cs typeface="Arial" pitchFamily="2" charset="0"/>
                 </a:rPr>
-                <a:t>Постановка задачи и основные понятия</a:t>
+                <a:t>Композиционный материал и прогнозируемые свойства</a:t>
               </a:r>
               <a:endParaRPr lang="ru-RU" sz="2600" b="1" spc="0" dirty="0">
                 <a:solidFill>
@@ -15463,8 +15463,25 @@
                 <a:latin typeface="Arial" panose="020B0604020202020204" pitchFamily="34" charset="0"/>
                 <a:cs typeface="Arial"/>
               </a:rPr>
-              <a:t>Матрица
-связующее, которое удерживает компоненты</a:t>
+              <a:t>Связующее (матрица)</a:t>
+            </a:r>
+          </a:p>
+          <a:p>
+            <a:pPr marL="0" indent="0" algn="l">
+              <a:lnSpc>
+                <a:spcPct val="100000"/>
+              </a:lnSpc>
+              <a:buNone/>
+            </a:pPr>
+            <a:r>
+              <a:rPr lang="ru-RU" sz="1900" i="0">
+                <a:solidFill>
+                  <a:srgbClr val="595959"/>
+                </a:solidFill>
+                <a:latin typeface="Arial" panose="020B0604020202020204" pitchFamily="34" charset="0"/>
+                <a:cs typeface="Arial"/>
+              </a:rPr>
+              <a:t>соединяет компоненты и передаёт нагрузку</a:t>
             </a:r>
             <a:endParaRPr sz="1900" i="0">
               <a:solidFill>
@@ -15609,8 +15626,25 @@
                 <a:latin typeface="Arial" panose="020B0604020202020204" pitchFamily="34" charset="0"/>
                 <a:cs typeface="Arial"/>
               </a:rPr>
-              <a:t>Наполнитель
-второй компонент, например усиливающие волокна</a:t>
+              <a:t>Наполнитель</a:t>
+            </a:r>
+          </a:p>
+          <a:p>
+            <a:pPr marL="0" indent="0" algn="l">
+              <a:lnSpc>
+                <a:spcPct val="100000"/>
+              </a:lnSpc>
+              <a:buNone/>
+            </a:pPr>
+            <a:r>
+              <a:rPr lang="ru-RU" sz="1900" i="0">
+                <a:solidFill>
+                  <a:srgbClr val="595959"/>
+                </a:solidFill>
+                <a:latin typeface="Arial" panose="020B0604020202020204" pitchFamily="34" charset="0"/>
+                <a:cs typeface="Arial"/>
+              </a:rPr>
+              <a:t>влияет на свойства; может усиливать материал</a:t>
             </a:r>
             <a:endParaRPr sz="1900" i="0">
               <a:solidFill>
@@ -15755,8 +15789,25 @@
                 <a:latin typeface="Arial" panose="020B0604020202020204" pitchFamily="34" charset="0"/>
                 <a:cs typeface="Arial"/>
               </a:rPr>
-              <a:t>Две характеристики
-модуль упругости и прочность при растяжении</a:t>
+              <a:t>Задача работы</a:t>
+            </a:r>
+          </a:p>
+          <a:p>
+            <a:pPr marL="0" indent="0" algn="l">
+              <a:lnSpc>
+                <a:spcPct val="100000"/>
+              </a:lnSpc>
+              <a:buNone/>
+            </a:pPr>
+            <a:r>
+              <a:rPr lang="ru-RU" sz="1900" i="0">
+                <a:solidFill>
+                  <a:srgbClr val="595959"/>
+                </a:solidFill>
+                <a:latin typeface="Arial" panose="020B0604020202020204" pitchFamily="34" charset="0"/>
+                <a:cs typeface="Arial"/>
+              </a:rPr>
+              <a:t>прогнозировать свойства по имеющимся характеристикам</a:t>
             </a:r>
             <a:endParaRPr sz="1900" i="0">
               <a:solidFill>
@@ -15825,18 +15876,118 @@
               <a:buNone/>
             </a:pPr>
             <a:r>
-              <a:rPr lang="ru-RU" sz="1800" i="0">
+              <a:rPr lang="ru-RU" sz="1600" i="0">
                 <a:solidFill>
                   <a:srgbClr val="262626"/>
                 </a:solidFill>
                 <a:latin typeface="Arial" panose="020B0604020202020204" pitchFamily="34" charset="0"/>
                 <a:cs typeface="Arial"/>
               </a:rPr>
-              <a:t>Цель
-Проверить, можно ли по параметрам состава и технологии оценить конечные свойства
-Расчёт не заменяет физическое испытание</a:t>
+              <a:t>Что прогнозируем</a:t>
             </a:r>
-            <a:endParaRPr sz="1800" i="0">
+          </a:p>
+          <a:p>
+            <a:pPr marL="0" indent="0" algn="l">
+              <a:lnSpc>
+                <a:spcPct val="105000"/>
+              </a:lnSpc>
+              <a:buNone/>
+            </a:pPr>
+            <a:endParaRPr lang="ru-RU" sz="1600" i="0">
+              <a:solidFill>
+                <a:srgbClr val="262626"/>
+              </a:solidFill>
+              <a:latin typeface="Arial" panose="020B0604020202020204" pitchFamily="34" charset="0"/>
+              <a:cs typeface="Arial"/>
+            </a:endParaRPr>
+          </a:p>
+          <a:p>
+            <a:pPr marL="0" indent="0" algn="l">
+              <a:lnSpc>
+                <a:spcPct val="105000"/>
+              </a:lnSpc>
+              <a:buNone/>
+            </a:pPr>
+            <a:r>
+              <a:rPr lang="ru-RU" sz="1600" i="0">
+                <a:solidFill>
+                  <a:srgbClr val="262626"/>
+                </a:solidFill>
+                <a:latin typeface="Arial" panose="020B0604020202020204" pitchFamily="34" charset="0"/>
+                <a:cs typeface="Arial"/>
+              </a:rPr>
+              <a:t>Модуль упругости при растяжении</a:t>
+            </a:r>
+          </a:p>
+          <a:p>
+            <a:pPr marL="0" indent="0" algn="l">
+              <a:lnSpc>
+                <a:spcPct val="105000"/>
+              </a:lnSpc>
+              <a:buNone/>
+            </a:pPr>
+            <a:r>
+              <a:rPr lang="ru-RU" sz="1600" i="0">
+                <a:solidFill>
+                  <a:srgbClr val="262626"/>
+                </a:solidFill>
+                <a:latin typeface="Arial" panose="020B0604020202020204" pitchFamily="34" charset="0"/>
+                <a:cs typeface="Arial"/>
+              </a:rPr>
+              <a:t>сопротивление обратимому растяжению</a:t>
+            </a:r>
+          </a:p>
+          <a:p>
+            <a:pPr marL="0" indent="0" algn="l">
+              <a:lnSpc>
+                <a:spcPct val="105000"/>
+              </a:lnSpc>
+              <a:buNone/>
+            </a:pPr>
+            <a:endParaRPr lang="ru-RU" sz="1600" i="0">
+              <a:solidFill>
+                <a:srgbClr val="262626"/>
+              </a:solidFill>
+              <a:latin typeface="Arial" panose="020B0604020202020204" pitchFamily="34" charset="0"/>
+              <a:cs typeface="Arial"/>
+            </a:endParaRPr>
+          </a:p>
+          <a:p>
+            <a:pPr marL="0" indent="0" algn="l">
+              <a:lnSpc>
+                <a:spcPct val="105000"/>
+              </a:lnSpc>
+              <a:buNone/>
+            </a:pPr>
+            <a:r>
+              <a:rPr lang="ru-RU" sz="1600" i="0">
+                <a:solidFill>
+                  <a:srgbClr val="262626"/>
+                </a:solidFill>
+                <a:latin typeface="Arial" panose="020B0604020202020204" pitchFamily="34" charset="0"/>
+                <a:cs typeface="Arial"/>
+              </a:rPr>
+              <a:t>Прочность при растяжении</a:t>
+            </a:r>
+          </a:p>
+          <a:p>
+            <a:pPr marL="0" indent="0" algn="l">
+              <a:lnSpc>
+                <a:spcPct val="105000"/>
+              </a:lnSpc>
+              <a:buNone/>
+            </a:pPr>
+            <a:r>
+              <a:rPr lang="ru-RU" sz="1600" i="0">
+                <a:solidFill>
+                  <a:srgbClr val="262626"/>
+                </a:solidFill>
+                <a:latin typeface="Arial" panose="020B0604020202020204" pitchFamily="34" charset="0"/>
+                <a:cs typeface="Arial"/>
+              </a:rPr>
+              <a:t>предельное напряжение до разрушения</a:t>
+            </a:r>
+            <a:endParaRPr sz="1600" i="0">
               <a:solidFill>
                 <a:srgbClr val="262626"/>
               </a:solidFill>
@@ -15870,15 +16021,22 @@
               <a:buNone/>
             </a:pPr>
             <a:r>
-              <a:rPr sz="1600" b="0" i="0">
+              <a:rPr lang="ru-RU" sz="1600" b="0" i="0">
                 <a:solidFill>
                   <a:srgbClr val="595959"/>
                 </a:solidFill>
                 <a:latin typeface="Arial" panose="020B0604020202020204" pitchFamily="34" charset="0"/>
                 <a:cs typeface="Arial"/>
               </a:rPr>
-              <a:t>Источник: РПЗ, табл. 1, с. 4</a:t>
+              <a:t>Источник: РПЗ, введение, с. 3</a:t>
             </a:r>
+            <a:endParaRPr sz="1600" b="0" i="0">
+              <a:solidFill>
+                <a:srgbClr val="595959"/>
+              </a:solidFill>
+              <a:latin typeface="Arial" panose="020B0604020202020204" pitchFamily="34" charset="0"/>
+              <a:cs typeface="Arial"/>
+            </a:endParaRPr>
           </a:p>
         </p:txBody>
       </p:sp>
@@ -16029,7 +16187,7 @@
                   <a:latin typeface="Arial" panose="020B0604020202020204" pitchFamily="34" charset="0"/>
                   <a:cs typeface="Arial" pitchFamily="2" charset="0"/>
                 </a:rPr>
-                <a:t>Из двух таблиц получено 1023 наблюдения</a:t>
+                <a:t>Исходные данные из двух таблиц</a:t>
               </a:r>
               <a:endParaRPr lang="ru-RU" sz="2600" b="1" spc="0" dirty="0">
                 <a:solidFill>
@@ -16770,7 +16928,7 @@
         <p:spPr>
           <a:xfrm>
             <a:off x="557784" y="3977639"/>
-            <a:ext cx="6766560" cy="411480"/>
+            <a:ext cx="6766560" cy="635000"/>
           </a:xfrm>
           <a:prstGeom prst="rect">
             <a:avLst/>
@@ -16785,16 +16943,31 @@
               <a:buNone/>
             </a:pPr>
             <a:r>
-              <a:rPr lang="ru-RU" sz="1600" i="0">
+              <a:rPr lang="ru-RU" sz="1300" i="0">
                 <a:solidFill>
                   <a:srgbClr val="595959"/>
                 </a:solidFill>
                 <a:latin typeface="Arial" panose="020B0604020202020204" pitchFamily="34" charset="0"/>
                 <a:cs typeface="Arial"/>
               </a:rPr>
-              <a:t>INNER JOIN оставляет только строки, которые присутствуют в обеих таблицах; сопоставление выполнено по исходному индексу</a:t>
+              <a:t>INNER JOIN: оставлены строки, присутствующие в обеих таблицах.</a:t>
             </a:r>
-            <a:endParaRPr sz="1600" i="0">
+          </a:p>
+          <a:p>
+            <a:pPr marL="0" indent="0" algn="l">
+              <a:buNone/>
+            </a:pPr>
+            <a:r>
+              <a:rPr lang="ru-RU" sz="1300" i="0">
+                <a:solidFill>
+                  <a:srgbClr val="595959"/>
+                </a:solidFill>
+                <a:latin typeface="Arial" panose="020B0604020202020204" pitchFamily="34" charset="0"/>
+                <a:cs typeface="Arial"/>
+              </a:rPr>
+              <a:t>Каждая итоговая строка содержит характеристики и известные конечные свойства.</a:t>
+            </a:r>
+            <a:endParaRPr sz="1300" i="0">
               <a:solidFill>
                 <a:srgbClr val="595959"/>
               </a:solidFill>
@@ -16937,8 +17110,22 @@
                 <a:latin typeface="Arial" panose="020B0604020202020204" pitchFamily="34" charset="0"/>
                 <a:cs typeface="Arial"/>
               </a:rPr>
-              <a:t>строк второй таблицы без пары
-они исключены при объединении</a:t>
+              <a:t>строк второй таблицы без пары</a:t>
+            </a:r>
+          </a:p>
+          <a:p>
+            <a:pPr marL="0" indent="0" algn="l">
+              <a:buNone/>
+            </a:pPr>
+            <a:r>
+              <a:rPr lang="ru-RU" sz="1900" i="0">
+                <a:solidFill>
+                  <a:srgbClr val="262626"/>
+                </a:solidFill>
+                <a:latin typeface="Arial" panose="020B0604020202020204" pitchFamily="34" charset="0"/>
+                <a:cs typeface="Arial"/>
+              </a:rPr>
+              <a:t>не вошли в итоговый набор</a:t>
             </a:r>
             <a:endParaRPr sz="1900" i="0">
               <a:solidFill>
@@ -17404,21 +17591,91 @@
                 <a:solidFill>
                   <a:srgbClr val="065CAB"/>
                 </a:solidFill>
-                <a:latin typeface="Arial" panose="020B0604020202020204" pitchFamily="34" charset="0"/>
                 <a:cs typeface="Arial"/>
               </a:rPr>
-              <a:t>Состав и компоненты
-Соотношение матрица–наполнитель; плотность; модуль упругости; отвердитель; эпоксидные группы; температура вспышки
-Поверхностные и расходные параметры
-Поверхностная плотность; потребление смолы
-Параметры нашивки
-Угол; шаг; плотность нашивки</a:t>
+              <a:t>Характеристики состава</a:t>
+            </a:r>
+          </a:p>
+          <a:p>
+            <a:pPr marL="0" indent="0" algn="l">
+              <a:lnSpc>
+                <a:spcPct val="100000"/>
+              </a:lnSpc>
+              <a:spcBef>
+                <a:spcPts val="0"/>
+              </a:spcBef>
+              <a:buNone/>
+            </a:pPr>
+            <a:r>
+              <a:rPr lang="ru-RU" sz="1600" i="0">
+                <a:solidFill>
+                  <a:srgbClr val="065CAB"/>
+                </a:solidFill>
+                <a:cs typeface="Arial"/>
+              </a:rPr>
+              <a:t>Соотношение матрица–наполнитель; плотность; модуль упругости; отвердитель; эпоксидные группы; температура вспышки</a:t>
+            </a:r>
+          </a:p>
+          <a:p>
+            <a:pPr marL="0" indent="0" algn="l">
+              <a:lnSpc>
+                <a:spcPct val="100000"/>
+              </a:lnSpc>
+              <a:spcBef>
+                <a:spcPts val="0"/>
+              </a:spcBef>
+              <a:buNone/>
+            </a:pPr>
+            <a:endParaRPr lang="ru-RU" sz="1600" i="0">
+              <a:solidFill>
+                <a:srgbClr val="065CAB"/>
+              </a:solidFill>
+              <a:cs typeface="Arial"/>
+            </a:endParaRPr>
+          </a:p>
+          <a:p>
+            <a:pPr marL="0" indent="0" algn="l">
+              <a:lnSpc>
+                <a:spcPct val="100000"/>
+              </a:lnSpc>
+              <a:spcBef>
+                <a:spcPts val="0"/>
+              </a:spcBef>
+              <a:buNone/>
+            </a:pPr>
+            <a:r>
+              <a:rPr lang="ru-RU" sz="1600" i="0">
+                <a:solidFill>
+                  <a:srgbClr val="065CAB"/>
+                </a:solidFill>
+                <a:cs typeface="Arial"/>
+              </a:rPr>
+              <a:t>Характеристики изготовления</a:t>
+            </a:r>
+          </a:p>
+          <a:p>
+            <a:pPr marL="0" indent="0" algn="l">
+              <a:lnSpc>
+                <a:spcPct val="100000"/>
+              </a:lnSpc>
+              <a:spcBef>
+                <a:spcPts val="0"/>
+              </a:spcBef>
+              <a:buNone/>
+            </a:pPr>
+            <a:r>
+              <a:rPr lang="ru-RU" sz="1600" i="0">
+                <a:solidFill>
+                  <a:srgbClr val="065CAB"/>
+                </a:solidFill>
+                <a:cs typeface="Arial"/>
+              </a:rPr>
+              <a:t>Поверхностная плотность; потребление смолы; угол, шаг и плотность нашивки</a:t>
             </a:r>
             <a:endParaRPr sz="1600" i="0">
               <a:solidFill>
                 <a:srgbClr val="262626"/>
               </a:solidFill>
-              <a:latin typeface="Arial" panose="020B0604020202020204" pitchFamily="34" charset="0"/>
               <a:cs typeface="Arial"/>
             </a:endParaRPr>
           </a:p>
@@ -17448,15 +17705,20 @@
               <a:buNone/>
             </a:pPr>
             <a:r>
-              <a:rPr sz="2000" b="1" i="0">
+              <a:rPr lang="ru-RU" sz="2000" b="1" i="0">
                 <a:solidFill>
                   <a:srgbClr val="F1BE29"/>
                 </a:solidFill>
-                <a:latin typeface="Arial" panose="020B0604020202020204" pitchFamily="34" charset="0"/>
                 <a:cs typeface="Arial"/>
               </a:rPr>
-              <a:t>Цели</a:t>
+              <a:t>Обучение, проверка и результат</a:t>
             </a:r>
+            <a:endParaRPr sz="2000" b="1" i="0">
+              <a:solidFill>
+                <a:srgbClr val="F1BE29"/>
+              </a:solidFill>
+              <a:cs typeface="Arial"/>
+            </a:endParaRPr>
           </a:p>
         </p:txBody>
       </p:sp>
@@ -17490,16 +17752,14 @@
                 <a:solidFill>
                   <a:srgbClr val="F1BE29"/>
                 </a:solidFill>
-                <a:latin typeface="Arial" panose="020B0604020202020204" pitchFamily="34" charset="0"/>
                 <a:cs typeface="Arial"/>
               </a:rPr>
-              <a:t>Входы прямых задач: 11 исходных полей</a:t>
+              <a:t>Вход прямых моделей: 11 характеристик</a:t>
             </a:r>
             <a:endParaRPr sz="1800" b="1" i="0">
               <a:solidFill>
                 <a:srgbClr val="F1BE29"/>
               </a:solidFill>
-              <a:latin typeface="Arial" panose="020B0604020202020204" pitchFamily="34" charset="0"/>
               <a:cs typeface="Arial"/>
             </a:endParaRPr>
           </a:p>
@@ -17583,7 +17843,7 @@
                   <a:latin typeface="Arial" panose="020B0604020202020204" pitchFamily="34" charset="0"/>
                   <a:cs typeface="Arial" pitchFamily="2" charset="0"/>
                 </a:rPr>
-                <a:t>Входные данные и три задачи регрессии</a:t>
+                <a:t>Как модель получает прогноз</a:t>
               </a:r>
               <a:endParaRPr lang="ru-RU" sz="2600" b="1" spc="0" dirty="0">
                 <a:solidFill>
@@ -17930,18 +18190,103 @@
               <a:buNone/>
             </a:pPr>
             <a:r>
-              <a:rPr lang="ru-RU" sz="1600" i="0">
+              <a:rPr lang="ru-RU" sz="1500" i="0">
                 <a:solidFill>
                   <a:srgbClr val="595959"/>
                 </a:solidFill>
                 <a:latin typeface="Arial" panose="020B0604020202020204" pitchFamily="34" charset="0"/>
                 <a:cs typeface="Arial"/>
               </a:rPr>
-              <a:t>Две прямые задачи
-Модуль упругости при растяжении, ГПа – жёсткость при обратимом растяжении
-Прочность при растяжении, МПа – предельное напряжение перед разрушением</a:t>
+              <a:t>Обучение и проверка</a:t>
             </a:r>
-            <a:endParaRPr sz="1600" i="0">
+          </a:p>
+          <a:p>
+            <a:pPr marL="0" indent="0" algn="l">
+              <a:lnSpc>
+                <a:spcPct val="100000"/>
+              </a:lnSpc>
+              <a:buNone/>
+            </a:pPr>
+            <a:r>
+              <a:rPr lang="ru-RU" sz="1500" i="0">
+                <a:solidFill>
+                  <a:srgbClr val="595959"/>
+                </a:solidFill>
+                <a:latin typeface="Arial" panose="020B0604020202020204" pitchFamily="34" charset="0"/>
+                <a:cs typeface="Arial"/>
+              </a:rPr>
+              <a:t>716 строк – обучающая выборка</a:t>
+            </a:r>
+          </a:p>
+          <a:p>
+            <a:pPr marL="0" indent="0" algn="l">
+              <a:lnSpc>
+                <a:spcPct val="100000"/>
+              </a:lnSpc>
+              <a:buNone/>
+            </a:pPr>
+            <a:r>
+              <a:rPr lang="ru-RU" sz="1500" i="0">
+                <a:solidFill>
+                  <a:srgbClr val="595959"/>
+                </a:solidFill>
+                <a:latin typeface="Arial" panose="020B0604020202020204" pitchFamily="34" charset="0"/>
+                <a:cs typeface="Arial"/>
+              </a:rPr>
+              <a:t>307 строк – независимая тестовая выборка</a:t>
+            </a:r>
+          </a:p>
+          <a:p>
+            <a:pPr marL="0" indent="0" algn="l">
+              <a:lnSpc>
+                <a:spcPct val="100000"/>
+              </a:lnSpc>
+              <a:buNone/>
+            </a:pPr>
+            <a:endParaRPr lang="ru-RU" sz="1500" i="0">
+              <a:solidFill>
+                <a:srgbClr val="595959"/>
+              </a:solidFill>
+              <a:latin typeface="Arial" panose="020B0604020202020204" pitchFamily="34" charset="0"/>
+              <a:cs typeface="Arial"/>
+            </a:endParaRPr>
+          </a:p>
+          <a:p>
+            <a:pPr marL="0" indent="0" algn="l">
+              <a:lnSpc>
+                <a:spcPct val="100000"/>
+              </a:lnSpc>
+              <a:buNone/>
+            </a:pPr>
+            <a:r>
+              <a:rPr lang="ru-RU" sz="1500" i="0">
+                <a:solidFill>
+                  <a:srgbClr val="595959"/>
+                </a:solidFill>
+                <a:latin typeface="Arial" panose="020B0604020202020204" pitchFamily="34" charset="0"/>
+                <a:cs typeface="Arial"/>
+              </a:rPr>
+              <a:t>Новый набор из 11 характеристик →</a:t>
+            </a:r>
+          </a:p>
+          <a:p>
+            <a:pPr marL="0" indent="0" algn="l">
+              <a:lnSpc>
+                <a:spcPct val="100000"/>
+              </a:lnSpc>
+              <a:buNone/>
+            </a:pPr>
+            <a:r>
+              <a:rPr lang="ru-RU" sz="1500" i="0">
+                <a:solidFill>
+                  <a:srgbClr val="595959"/>
+                </a:solidFill>
+                <a:latin typeface="Arial" panose="020B0604020202020204" pitchFamily="34" charset="0"/>
+                <a:cs typeface="Arial"/>
+              </a:rPr>
+              <a:t>две оценки: модуль, ГПа, и прочность, МПа</a:t>
+            </a:r>
+            <a:endParaRPr sz="1500" i="0">
               <a:solidFill>
                 <a:srgbClr val="595959"/>
               </a:solidFill>
@@ -18008,18 +18353,70 @@
               <a:buNone/>
             </a:pPr>
             <a:r>
-              <a:rPr lang="ru-RU" sz="1600" i="0">
+              <a:rPr lang="ru-RU" i="0">
                 <a:solidFill>
                   <a:srgbClr val="595959"/>
                 </a:solidFill>
                 <a:latin typeface="Arial" panose="020B0604020202020204" pitchFamily="34" charset="0"/>
                 <a:cs typeface="Arial"/>
               </a:rPr>
-              <a:t>Отдельная задача отношения
-12 известных полей, включая известные модуль и прочность
-Результат: соотношение матрица–наполнитель</a:t>
+              <a:t>Дополнительная задача</a:t>
             </a:r>
-            <a:endParaRPr sz="1600" i="0">
+          </a:p>
+          <a:p>
+            <a:pPr marL="0" indent="0" algn="l">
+              <a:lnSpc>
+                <a:spcPct val="100000"/>
+              </a:lnSpc>
+              <a:buNone/>
+            </a:pPr>
+            <a:r>
+              <a:rPr lang="ru-RU" i="0">
+                <a:solidFill>
+                  <a:srgbClr val="595959"/>
+                </a:solidFill>
+                <a:latin typeface="Arial" panose="020B0604020202020204" pitchFamily="34" charset="0"/>
+                <a:cs typeface="Arial"/>
+              </a:rPr>
+              <a:t>12 известных показателей, включая известные модуль и прочность →</a:t>
+            </a:r>
+          </a:p>
+          <a:p>
+            <a:pPr marL="0" indent="0" algn="l">
+              <a:lnSpc>
+                <a:spcPct val="100000"/>
+              </a:lnSpc>
+              <a:buNone/>
+            </a:pPr>
+            <a:r>
+              <a:rPr lang="ru-RU" i="0">
+                <a:solidFill>
+                  <a:srgbClr val="595959"/>
+                </a:solidFill>
+                <a:latin typeface="Arial" panose="020B0604020202020204" pitchFamily="34" charset="0"/>
+                <a:cs typeface="Arial"/>
+              </a:rPr>
+              <a:t>соотношение матрица–наполнитель</a:t>
+            </a:r>
+          </a:p>
+          <a:p>
+            <a:pPr marL="0" indent="0" algn="l">
+              <a:lnSpc>
+                <a:spcPct val="100000"/>
+              </a:lnSpc>
+              <a:buNone/>
+            </a:pPr>
+            <a:r>
+              <a:rPr lang="ru-RU" i="0">
+                <a:solidFill>
+                  <a:srgbClr val="595959"/>
+                </a:solidFill>
+                <a:latin typeface="Arial" panose="020B0604020202020204" pitchFamily="34" charset="0"/>
+                <a:cs typeface="Arial"/>
+              </a:rPr>
+              <a:t>В приложение не включена</a:t>
+            </a:r>
+            <a:endParaRPr i="0">
               <a:solidFill>
                 <a:srgbClr val="065CAB"/>
               </a:solidFill>
@@ -18056,16 +18453,16 @@
               <a:buNone/>
             </a:pPr>
             <a:r>
-              <a:rPr lang="ru-RU" b="1" i="0">
+              <a:rPr lang="ru-RU" sz="1000" b="1" i="0">
                 <a:solidFill>
                   <a:srgbClr val="595959"/>
                 </a:solidFill>
                 <a:latin typeface="Arial" panose="020B0604020202020204" pitchFamily="34" charset="0"/>
                 <a:cs typeface="Arial"/>
               </a:rPr>
-              <a:t>Входной «модуль упругости» и целевой «модуль упругости при растяжении» – разные столбцы. Обе цели исключены из входов прямых моделей. Задача отношения не подбирает рецептуру.</a:t>
+              <a:t>Конечные свойства исключены из 11 входов прямых моделей. Входной «модуль упругости» и целевой «модуль упругости при растяжении» – разные столбцы.</a:t>
             </a:r>
-            <a:endParaRPr b="1" i="0">
+            <a:endParaRPr sz="1000" b="1" i="0">
               <a:solidFill>
                 <a:srgbClr val="595959"/>
               </a:solidFill>
@@ -18099,15 +18496,22 @@
               <a:buNone/>
             </a:pPr>
             <a:r>
-              <a:rPr sz="1600" b="0" i="0">
+              <a:rPr lang="ru-RU" sz="1600" b="0" i="0">
                 <a:solidFill>
                   <a:srgbClr val="595959"/>
                 </a:solidFill>
                 <a:latin typeface="Arial" panose="020B0604020202020204" pitchFamily="34" charset="0"/>
                 <a:cs typeface="Arial"/>
               </a:rPr>
-              <a:t>Источник: РПЗ, табл. 1, с. 4; словарь данных репозитория</a:t>
+              <a:t>Источник: РПЗ, разд. 1.1, с. 4–5; словарь данных репозитория</a:t>
             </a:r>
+            <a:endParaRPr sz="1600" b="0" i="0">
+              <a:solidFill>
+                <a:srgbClr val="595959"/>
+              </a:solidFill>
+              <a:latin typeface="Arial" panose="020B0604020202020204" pitchFamily="34" charset="0"/>
+              <a:cs typeface="Arial"/>
+            </a:endParaRPr>
           </a:p>
         </p:txBody>
       </p:sp>

</xml_diff>

<commit_message>
docs: rewrite thesis in plain language and align references
</commit_message>
<xml_diff>
--- a/presentation/Презентация.pptx
+++ b/presentation/Презентация.pptx
@@ -1290,7 +1290,7 @@
               <a:t>Свойства готового материала зависят от сочетания компонентов и условий изготовления. Задача работы – прогнозировать эти свойства по имеющимся характеристикам.
 Связующее, или матрица, соединяет компоненты в единый материал и передаёт нагрузку. Наполнитель влияет на свойства материала и может выполнять армирующую функцию, то есть усиливать материал.
 В работе оцениваются две конечные характеристики. Модуль упругости при растяжении показывает сопротивление обратимому растяжению: после снятия нагрузки форма восстанавливается. Прочность при растяжении – предельное напряжение перед разрушением. Напряжение здесь означает нагрузку на единицу площади поперечного сечения.
-Источники: РПЗ, введение, с. 3.</a:t>
+Источники: РПЗ, введение.</a:t>
             </a:r>
             <a:endParaRPr>
               <a:latin typeface="Arial" panose="020B0604020202020204" pitchFamily="34" charset="0"/>
@@ -1361,7 +1361,7 @@
               </a:rPr>
               <a:t>Исходные данные находились в двух таблицах Excel, которые дополняют друг друга. Применён INNER JOIN: таблицы сопоставили по исходному индексу и оставили только строки, присутствующие в обеих таблицах. Получено 1023 наблюдения с 13 показателями; 17 строк второй таблицы без пары не вошли в итоговый набор. Пропусков и полных дубликатов нет.
 После объединения каждая строка содержит характеристики и известные конечные свойства. Такая строка служит примером, на котором можно обучать и проверять модель. Происхождение образцов, группы, партии и часть единиц измерения не описаны; это ограничение учитывается при интерпретации результатов.
-Источники: РПЗ, таблица 4; docs/data_dictionary.md.</a:t>
+Источники: РПЗ, таблица 5; docs/data_dictionary.md.</a:t>
             </a:r>
             <a:endParaRPr>
               <a:latin typeface="Arial" panose="020B0604020202020204" pitchFamily="34" charset="0"/>
@@ -1433,7 +1433,7 @@
               <a:t>Для прямого прогнозирования используются 11 характеристик состава и технологии. Из 1023 строк 716 образуют обучающую выборку, а 307 – независимую тестовую выборку. На обучающей части модель учится связывать 11 входных характеристик с известными конечными свойствами, а тестовая часть показывает качество на данных, которые не использовались при обучении.
 Для нового набора из 11 характеристик модель выдаёт две оценки: модуль упругости при растяжении в гигапаскалях и прочность при растяжении в мегапаскалях. Сами конечные свойства в эти 11 входов не входят.
 Отдельно решается дополнительная задача: по 12 другим известным показателям, включая известные модуль и прочность, оценивается соотношение матрица–наполнитель. Эта задача отделена от двух прямых прогнозов и в приложение не включена.
-Источники: РПЗ, раздел 1.1, с. 4–5; docs/data_dictionary.md.</a:t>
+Источники: РПЗ, раздел 1.1; docs/data_dictionary.md.</a:t>
             </a:r>
             <a:endParaRPr>
               <a:latin typeface="Arial" panose="020B0604020202020204" pitchFamily="34" charset="0"/>
@@ -8900,15 +8900,32 @@
               <a:buNone/>
             </a:pPr>
             <a:r>
-              <a:rPr sz="1600" b="0" i="0">
+              <a:rPr lang="ru-RU" sz="1600" b="0" i="0">
                 <a:solidFill>
                   <a:srgbClr val="595959"/>
                 </a:solidFill>
                 <a:latin typeface="Arial" panose="020B0604020202020204" pitchFamily="34" charset="0"/>
                 <a:cs typeface="Arial"/>
               </a:rPr>
-              <a:t>Источник: РПЗ, рис. 8, с. 21; reports/evaluation/metrics.csv</a:t>
+              <a:t>Источник: РПЗ, рис. 8; </a:t>
             </a:r>
+            <a:r>
+              <a:rPr lang="en-US" sz="1600" b="0" i="0">
+                <a:solidFill>
+                  <a:srgbClr val="595959"/>
+                </a:solidFill>
+                <a:latin typeface="Arial" panose="020B0604020202020204" pitchFamily="34" charset="0"/>
+                <a:cs typeface="Arial"/>
+              </a:rPr>
+              <a:t>reports/evaluation/metrics.csv</a:t>
+            </a:r>
+            <a:endParaRPr sz="1600" b="0" i="0">
+              <a:solidFill>
+                <a:srgbClr val="595959"/>
+              </a:solidFill>
+              <a:latin typeface="Arial" panose="020B0604020202020204" pitchFamily="34" charset="0"/>
+              <a:cs typeface="Arial"/>
+            </a:endParaRPr>
           </a:p>
         </p:txBody>
       </p:sp>
@@ -10148,15 +10165,22 @@
               <a:buNone/>
             </a:pPr>
             <a:r>
-              <a:rPr sz="1600" b="0" i="0">
+              <a:rPr lang="ru-RU" sz="1600" b="0" i="0">
                 <a:solidFill>
                   <a:srgbClr val="595959"/>
                 </a:solidFill>
                 <a:latin typeface="Arial" panose="020B0604020202020204" pitchFamily="34" charset="0"/>
                 <a:cs typeface="Arial"/>
               </a:rPr>
-              <a:t>Источник: РПЗ, разд. 2.4, с. 24</a:t>
+              <a:t>Источник: РПЗ, разд. 2.4</a:t>
             </a:r>
+            <a:endParaRPr sz="1600" b="0" i="0">
+              <a:solidFill>
+                <a:srgbClr val="595959"/>
+              </a:solidFill>
+              <a:latin typeface="Arial" panose="020B0604020202020204" pitchFamily="34" charset="0"/>
+              <a:cs typeface="Arial"/>
+            </a:endParaRPr>
           </a:p>
         </p:txBody>
       </p:sp>
@@ -12413,15 +12437,22 @@
               <a:buNone/>
             </a:pPr>
             <a:r>
-              <a:rPr sz="1600" b="0" i="0">
+              <a:rPr lang="ru-RU" sz="1600" b="0" i="0">
                 <a:solidFill>
                   <a:srgbClr val="595959"/>
                 </a:solidFill>
                 <a:latin typeface="Arial" panose="020B0604020202020204" pitchFamily="34" charset="0"/>
                 <a:cs typeface="Arial"/>
               </a:rPr>
-              <a:t>Источник: РПЗ, рис. 10, с. 23</a:t>
+              <a:t>Источник: РПЗ, рис. 10</a:t>
             </a:r>
+            <a:endParaRPr sz="1600" b="0" i="0">
+              <a:solidFill>
+                <a:srgbClr val="595959"/>
+              </a:solidFill>
+              <a:latin typeface="Arial" panose="020B0604020202020204" pitchFamily="34" charset="0"/>
+              <a:cs typeface="Arial"/>
+            </a:endParaRPr>
           </a:p>
         </p:txBody>
       </p:sp>
@@ -13658,15 +13689,32 @@
               <a:buNone/>
             </a:pPr>
             <a:r>
-              <a:rPr sz="1600" b="0" i="0">
+              <a:rPr lang="ru-RU" sz="1600" b="0" i="0">
                 <a:solidFill>
                   <a:srgbClr val="595959"/>
                 </a:solidFill>
                 <a:latin typeface="Arial" panose="020B0604020202020204" pitchFamily="34" charset="0"/>
                 <a:cs typeface="Arial"/>
               </a:rPr>
-              <a:t>Источник: РПЗ, разд. 2.5, с. 25; docs/application.md</a:t>
+              <a:t>Источник: РПЗ, разд. 2.5; </a:t>
             </a:r>
+            <a:r>
+              <a:rPr lang="en-US" sz="1600" b="0" i="0">
+                <a:solidFill>
+                  <a:srgbClr val="595959"/>
+                </a:solidFill>
+                <a:latin typeface="Arial" panose="020B0604020202020204" pitchFamily="34" charset="0"/>
+                <a:cs typeface="Arial"/>
+              </a:rPr>
+              <a:t>docs/application.md</a:t>
+            </a:r>
+            <a:endParaRPr sz="1600" b="0" i="0">
+              <a:solidFill>
+                <a:srgbClr val="595959"/>
+              </a:solidFill>
+              <a:latin typeface="Arial" panose="020B0604020202020204" pitchFamily="34" charset="0"/>
+              <a:cs typeface="Arial"/>
+            </a:endParaRPr>
           </a:p>
         </p:txBody>
       </p:sp>
@@ -16028,7 +16076,7 @@
                 <a:latin typeface="Arial" panose="020B0604020202020204" pitchFamily="34" charset="0"/>
                 <a:cs typeface="Arial"/>
               </a:rPr>
-              <a:t>Источник: РПЗ, введение, с. 3</a:t>
+              <a:t>Источник: РПЗ, введение</a:t>
             </a:r>
             <a:endParaRPr sz="1600" b="0" i="0">
               <a:solidFill>
@@ -17474,15 +17522,22 @@
               <a:buNone/>
             </a:pPr>
             <a:r>
-              <a:rPr sz="1600" b="0" i="0">
+              <a:rPr lang="ru-RU" sz="1600" b="0" i="0">
                 <a:solidFill>
                   <a:srgbClr val="595959"/>
                 </a:solidFill>
                 <a:latin typeface="Arial" panose="020B0604020202020204" pitchFamily="34" charset="0"/>
                 <a:cs typeface="Arial"/>
               </a:rPr>
-              <a:t>Источник: РПЗ, табл. 4, с. 11; словарь данных репозитория</a:t>
+              <a:t>Источник: РПЗ, табл. 5; словарь данных репозитория</a:t>
             </a:r>
+            <a:endParaRPr sz="1600" b="0" i="0">
+              <a:solidFill>
+                <a:srgbClr val="595959"/>
+              </a:solidFill>
+              <a:latin typeface="Arial" panose="020B0604020202020204" pitchFamily="34" charset="0"/>
+              <a:cs typeface="Arial"/>
+            </a:endParaRPr>
           </a:p>
         </p:txBody>
       </p:sp>
@@ -18503,7 +18558,7 @@
                 <a:latin typeface="Arial" panose="020B0604020202020204" pitchFamily="34" charset="0"/>
                 <a:cs typeface="Arial"/>
               </a:rPr>
-              <a:t>Источник: РПЗ, разд. 1.1, с. 4–5; словарь данных репозитория</a:t>
+              <a:t>Источник: РПЗ, разд. 1.1; словарь данных репозитория</a:t>
             </a:r>
             <a:endParaRPr sz="1600" b="0" i="0">
               <a:solidFill>
@@ -19785,7 +19840,7 @@
                 <a:latin typeface="Arial" panose="020B0604020202020204" pitchFamily="34" charset="0"/>
                 <a:cs typeface="Arial"/>
               </a:rPr>
-              <a:t>Настройки и численное сравнение: РПЗ, таблица 6</a:t>
+              <a:t>Результаты сравнения: РПЗ, таблица 6</a:t>
             </a:r>
             <a:endParaRPr sz="1500" i="0">
               <a:solidFill>
@@ -19868,15 +19923,32 @@
               <a:buNone/>
             </a:pPr>
             <a:r>
-              <a:rPr sz="1600" b="0" i="0">
+              <a:rPr lang="ru-RU" sz="1600" b="0" i="0">
                 <a:solidFill>
                   <a:srgbClr val="595959"/>
                 </a:solidFill>
                 <a:latin typeface="Arial" panose="020B0604020202020204" pitchFamily="34" charset="0"/>
                 <a:cs typeface="Arial"/>
               </a:rPr>
-              <a:t>Источник: РПЗ, табл. 6, с. 19; reports/modeling/cv_summary.csv</a:t>
+              <a:t>Источник: РПЗ, табл. 6; </a:t>
             </a:r>
+            <a:r>
+              <a:rPr lang="en-US" sz="1600" b="0" i="0">
+                <a:solidFill>
+                  <a:srgbClr val="595959"/>
+                </a:solidFill>
+                <a:latin typeface="Arial" panose="020B0604020202020204" pitchFamily="34" charset="0"/>
+                <a:cs typeface="Arial"/>
+              </a:rPr>
+              <a:t>reports/modeling/cv_summary.csv</a:t>
+            </a:r>
+            <a:endParaRPr sz="1600" b="0" i="0">
+              <a:solidFill>
+                <a:srgbClr val="595959"/>
+              </a:solidFill>
+              <a:latin typeface="Arial" panose="020B0604020202020204" pitchFamily="34" charset="0"/>
+              <a:cs typeface="Arial"/>
+            </a:endParaRPr>
           </a:p>
         </p:txBody>
       </p:sp>
@@ -20752,15 +20824,22 @@
               <a:buNone/>
             </a:pPr>
             <a:r>
-              <a:rPr sz="1600" b="0" i="0">
+              <a:rPr lang="ru-RU" sz="1600" b="0" i="0">
                 <a:solidFill>
                   <a:srgbClr val="595959"/>
                 </a:solidFill>
                 <a:latin typeface="Arial" panose="020B0604020202020204" pitchFamily="34" charset="0"/>
                 <a:cs typeface="Arial"/>
               </a:rPr>
-              <a:t>Источник: РПЗ, рис. 1, с. 10</a:t>
+              <a:t>Источник: РПЗ, рис. 1</a:t>
             </a:r>
+            <a:endParaRPr sz="1600" b="0" i="0">
+              <a:solidFill>
+                <a:srgbClr val="595959"/>
+              </a:solidFill>
+              <a:latin typeface="Arial" panose="020B0604020202020204" pitchFamily="34" charset="0"/>
+              <a:cs typeface="Arial"/>
+            </a:endParaRPr>
           </a:p>
         </p:txBody>
       </p:sp>
@@ -21883,15 +21962,22 @@
               <a:buNone/>
             </a:pPr>
             <a:r>
-              <a:rPr sz="1600" b="0" i="0">
+              <a:rPr lang="ru-RU" sz="1600" b="0" i="0">
                 <a:solidFill>
                   <a:srgbClr val="595959"/>
                 </a:solidFill>
                 <a:latin typeface="Arial" panose="020B0604020202020204" pitchFamily="34" charset="0"/>
                 <a:cs typeface="Arial"/>
               </a:rPr>
-              <a:t>Источник: РПЗ, разд. 2.1.3, с. 17</a:t>
+              <a:t>Источник: РПЗ, разд. 2.1.3</a:t>
             </a:r>
+            <a:endParaRPr sz="1600" b="0" i="0">
+              <a:solidFill>
+                <a:srgbClr val="595959"/>
+              </a:solidFill>
+              <a:latin typeface="Arial" panose="020B0604020202020204" pitchFamily="34" charset="0"/>
+              <a:cs typeface="Arial"/>
+            </a:endParaRPr>
           </a:p>
         </p:txBody>
       </p:sp>
@@ -24189,15 +24275,32 @@
               <a:buNone/>
             </a:pPr>
             <a:r>
-              <a:rPr sz="1600" b="0" i="0">
+              <a:rPr lang="ru-RU" sz="1600" b="0" i="0">
                 <a:solidFill>
                   <a:srgbClr val="595959"/>
                 </a:solidFill>
                 <a:latin typeface="Arial" panose="020B0604020202020204" pitchFamily="34" charset="0"/>
                 <a:cs typeface="Arial"/>
               </a:rPr>
-              <a:t>Источник: РПЗ, рис. 8, с. 21; reports/evaluation/metrics.csv</a:t>
+              <a:t>Источник: РПЗ, рис. 8; </a:t>
             </a:r>
+            <a:r>
+              <a:rPr lang="en-US" sz="1600" b="0" i="0">
+                <a:solidFill>
+                  <a:srgbClr val="595959"/>
+                </a:solidFill>
+                <a:latin typeface="Arial" panose="020B0604020202020204" pitchFamily="34" charset="0"/>
+                <a:cs typeface="Arial"/>
+              </a:rPr>
+              <a:t>reports/evaluation/metrics.csv</a:t>
+            </a:r>
+            <a:endParaRPr sz="1600" b="0" i="0">
+              <a:solidFill>
+                <a:srgbClr val="595959"/>
+              </a:solidFill>
+              <a:latin typeface="Arial" panose="020B0604020202020204" pitchFamily="34" charset="0"/>
+              <a:cs typeface="Arial"/>
+            </a:endParaRPr>
           </a:p>
         </p:txBody>
       </p:sp>

</xml_diff>

<commit_message>
fix: remove presentation placeholders and source footers
</commit_message>
<xml_diff>
--- a/presentation/Презентация.pptx
+++ b/presentation/Презентация.pptx
@@ -8876,49 +8876,6 @@
       </p:sp>
       <p:sp>
         <p:nvSpPr>
-          <p:cNvPr id="83" name="Источник"/>
-          <p:cNvSpPr txBox="1"/>
-          <p:nvPr/>
-        </p:nvSpPr>
-        <p:spPr>
-          <a:xfrm>
-            <a:off x="960120" y="6336792"/>
-            <a:ext cx="10808208" cy="365760"/>
-          </a:xfrm>
-          <a:prstGeom prst="rect">
-            <a:avLst/>
-          </a:prstGeom>
-          <a:noFill/>
-        </p:spPr>
-        <p:txBody>
-          <a:bodyPr wrap="square" lIns="0" tIns="0" rIns="0" bIns="0" anchor="ctr"/>
-          <a:lstStyle/>
-          <a:p>
-            <a:pPr marL="0" indent="0" algn="l">
-              <a:buNone/>
-            </a:pPr>
-            <a:r>
-              <a:rPr lang="ru-RU" sz="1300" i="0">
-                <a:solidFill>
-                  <a:srgbClr val="595959"/>
-                </a:solidFill>
-                <a:latin typeface="Arial" panose="020B0604020202020204" pitchFamily="34" charset="0"/>
-                <a:cs typeface="Arial"/>
-              </a:rPr>
-              <a:t>Источник: РПЗ, рисунок с фактическими и прогнозными значениями; reports/evaluation/metrics.csv</a:t>
-            </a:r>
-            <a:endParaRPr sz="1300" i="0">
-              <a:solidFill>
-                <a:srgbClr val="595959"/>
-              </a:solidFill>
-              <a:latin typeface="Arial" panose="020B0604020202020204" pitchFamily="34" charset="0"/>
-              <a:cs typeface="Arial"/>
-            </a:endParaRPr>
-          </a:p>
-        </p:txBody>
-      </p:sp>
-      <p:sp>
-        <p:nvSpPr>
           <p:cNvPr id="4" name="Номер слайда 3">
             <a:extLst>
               <a:ext uri="{FF2B5EF4-FFF2-40B4-BE49-F238E27FC236}">
@@ -9848,49 +9805,6 @@
       </p:cxnSp>
       <p:sp>
         <p:nvSpPr>
-          <p:cNvPr id="91" name="Источник"/>
-          <p:cNvSpPr txBox="1"/>
-          <p:nvPr/>
-        </p:nvSpPr>
-        <p:spPr>
-          <a:xfrm>
-            <a:off x="960120" y="6336792"/>
-            <a:ext cx="10808208" cy="365760"/>
-          </a:xfrm>
-          <a:prstGeom prst="rect">
-            <a:avLst/>
-          </a:prstGeom>
-          <a:noFill/>
-        </p:spPr>
-        <p:txBody>
-          <a:bodyPr wrap="square" lIns="0" tIns="0" rIns="0" bIns="0" anchor="ctr"/>
-          <a:lstStyle/>
-          <a:p>
-            <a:pPr marL="0" indent="0" algn="l">
-              <a:buNone/>
-            </a:pPr>
-            <a:r>
-              <a:rPr lang="ru-RU" sz="1300" i="0">
-                <a:solidFill>
-                  <a:srgbClr val="595959"/>
-                </a:solidFill>
-                <a:latin typeface="Arial" panose="020B0604020202020204" pitchFamily="34" charset="0"/>
-                <a:cs typeface="Arial"/>
-              </a:rPr>
-              <a:t>Источник: РПЗ, раздел о нейросети</a:t>
-            </a:r>
-            <a:endParaRPr sz="1300" i="0">
-              <a:solidFill>
-                <a:srgbClr val="595959"/>
-              </a:solidFill>
-              <a:latin typeface="Arial" panose="020B0604020202020204" pitchFamily="34" charset="0"/>
-              <a:cs typeface="Arial"/>
-            </a:endParaRPr>
-          </a:p>
-        </p:txBody>
-      </p:sp>
-      <p:sp>
-        <p:nvSpPr>
           <p:cNvPr id="4" name="Номер слайда 3">
             <a:extLst>
               <a:ext uri="{FF2B5EF4-FFF2-40B4-BE49-F238E27FC236}">
@@ -10497,59 +10411,6 @@
           </p:txBody>
         </p:sp>
       </p:grpSp>
-      <p:sp>
-        <p:nvSpPr>
-          <p:cNvPr id="73" name="Источник"/>
-          <p:cNvSpPr txBox="1"/>
-          <p:nvPr/>
-        </p:nvSpPr>
-        <p:spPr>
-          <a:xfrm>
-            <a:off x="960120" y="6336792"/>
-            <a:ext cx="10808208" cy="365760"/>
-          </a:xfrm>
-          <a:prstGeom prst="rect">
-            <a:avLst/>
-          </a:prstGeom>
-          <a:noFill/>
-        </p:spPr>
-        <p:txBody>
-          <a:bodyPr wrap="square" lIns="0" tIns="0" rIns="0" bIns="0" anchor="ctr"/>
-          <a:lstStyle/>
-          <a:p>
-            <a:pPr marL="0" indent="0" algn="l">
-              <a:buNone/>
-            </a:pPr>
-            <a:r>
-              <a:rPr lang="ru-RU" sz="1300" i="0">
-                <a:solidFill>
-                  <a:srgbClr val="595959"/>
-                </a:solidFill>
-                <a:latin typeface="Arial" panose="020B0604020202020204" pitchFamily="34" charset="0"/>
-                <a:cs typeface="Arial"/>
-              </a:rPr>
-              <a:t>Источник: РПЗ, таблица результатов нейросети; </a:t>
-            </a:r>
-            <a:r>
-              <a:rPr lang="en-US" sz="1300" i="0">
-                <a:solidFill>
-                  <a:srgbClr val="595959"/>
-                </a:solidFill>
-                <a:latin typeface="Arial" panose="020B0604020202020204" pitchFamily="34" charset="0"/>
-                <a:cs typeface="Arial"/>
-              </a:rPr>
-              <a:t>reports/evaluation/metrics.csv</a:t>
-            </a:r>
-            <a:endParaRPr sz="1300" i="0">
-              <a:solidFill>
-                <a:srgbClr val="595959"/>
-              </a:solidFill>
-              <a:latin typeface="Arial" panose="020B0604020202020204" pitchFamily="34" charset="0"/>
-              <a:cs typeface="Arial"/>
-            </a:endParaRPr>
-          </a:p>
-        </p:txBody>
-      </p:sp>
       <p:sp>
         <p:nvSpPr>
           <p:cNvPr id="4" name="Номер слайда 3">
@@ -11645,59 +11506,6 @@
       </p:sp>
       <p:sp>
         <p:nvSpPr>
-          <p:cNvPr id="78" name="Источник"/>
-          <p:cNvSpPr txBox="1"/>
-          <p:nvPr/>
-        </p:nvSpPr>
-        <p:spPr>
-          <a:xfrm>
-            <a:off x="960120" y="6336792"/>
-            <a:ext cx="10808208" cy="365760"/>
-          </a:xfrm>
-          <a:prstGeom prst="rect">
-            <a:avLst/>
-          </a:prstGeom>
-          <a:noFill/>
-        </p:spPr>
-        <p:txBody>
-          <a:bodyPr wrap="square" lIns="0" tIns="0" rIns="0" bIns="0" anchor="ctr"/>
-          <a:lstStyle/>
-          <a:p>
-            <a:pPr marL="0" indent="0" algn="l">
-              <a:buNone/>
-            </a:pPr>
-            <a:r>
-              <a:rPr lang="ru-RU" sz="1300" i="0">
-                <a:solidFill>
-                  <a:srgbClr val="595959"/>
-                </a:solidFill>
-                <a:latin typeface="Arial" panose="020B0604020202020204" pitchFamily="34" charset="0"/>
-                <a:cs typeface="Arial"/>
-              </a:rPr>
-              <a:t>Источник: РПЗ, рисунок с важностью характеристик; </a:t>
-            </a:r>
-            <a:r>
-              <a:rPr lang="en-US" sz="1300" i="0">
-                <a:solidFill>
-                  <a:srgbClr val="595959"/>
-                </a:solidFill>
-                <a:latin typeface="Arial" panose="020B0604020202020204" pitchFamily="34" charset="0"/>
-                <a:cs typeface="Arial"/>
-              </a:rPr>
-              <a:t>reports/evaluation/permutation_importance.csv</a:t>
-            </a:r>
-            <a:endParaRPr sz="1300" i="0">
-              <a:solidFill>
-                <a:srgbClr val="595959"/>
-              </a:solidFill>
-              <a:latin typeface="Arial" panose="020B0604020202020204" pitchFamily="34" charset="0"/>
-              <a:cs typeface="Arial"/>
-            </a:endParaRPr>
-          </a:p>
-        </p:txBody>
-      </p:sp>
-      <p:sp>
-        <p:nvSpPr>
           <p:cNvPr id="4" name="Номер слайда 3">
             <a:extLst>
               <a:ext uri="{FF2B5EF4-FFF2-40B4-BE49-F238E27FC236}">
@@ -13007,49 +12815,6 @@
       </p:sp>
       <p:sp>
         <p:nvSpPr>
-          <p:cNvPr id="91" name="Источник"/>
-          <p:cNvSpPr txBox="1"/>
-          <p:nvPr/>
-        </p:nvSpPr>
-        <p:spPr>
-          <a:xfrm>
-            <a:off x="960120" y="6336792"/>
-            <a:ext cx="10808208" cy="365760"/>
-          </a:xfrm>
-          <a:prstGeom prst="rect">
-            <a:avLst/>
-          </a:prstGeom>
-          <a:noFill/>
-        </p:spPr>
-        <p:txBody>
-          <a:bodyPr wrap="square" lIns="0" tIns="0" rIns="0" bIns="0" anchor="ctr"/>
-          <a:lstStyle/>
-          <a:p>
-            <a:pPr marL="0" indent="0" algn="l">
-              <a:buNone/>
-            </a:pPr>
-            <a:r>
-              <a:rPr lang="ru-RU" sz="1300" i="0">
-                <a:solidFill>
-                  <a:srgbClr val="595959"/>
-                </a:solidFill>
-                <a:latin typeface="Arial" panose="020B0604020202020204" pitchFamily="34" charset="0"/>
-                <a:cs typeface="Arial"/>
-              </a:rPr>
-              <a:t>Источник: РПЗ, раздел о приложении и репозитории; docs/application.md</a:t>
-            </a:r>
-            <a:endParaRPr sz="1300" i="0">
-              <a:solidFill>
-                <a:srgbClr val="595959"/>
-              </a:solidFill>
-              <a:latin typeface="Arial" panose="020B0604020202020204" pitchFamily="34" charset="0"/>
-              <a:cs typeface="Arial"/>
-            </a:endParaRPr>
-          </a:p>
-        </p:txBody>
-      </p:sp>
-      <p:sp>
-        <p:nvSpPr>
           <p:cNvPr id="2" name="Номер слайда 3">
             <a:extLst>
               <a:ext uri="{FF2B5EF4-FFF2-40B4-BE49-F238E27FC236}">
@@ -14206,69 +13971,6 @@
       </p:sp>
       <p:sp>
         <p:nvSpPr>
-          <p:cNvPr id="92" name="Источник"/>
-          <p:cNvSpPr txBox="1"/>
-          <p:nvPr/>
-        </p:nvSpPr>
-        <p:spPr>
-          <a:xfrm>
-            <a:off x="960120" y="6336792"/>
-            <a:ext cx="10808208" cy="365760"/>
-          </a:xfrm>
-          <a:prstGeom prst="rect">
-            <a:avLst/>
-          </a:prstGeom>
-          <a:noFill/>
-        </p:spPr>
-        <p:txBody>
-          <a:bodyPr wrap="square" lIns="0" tIns="0" rIns="0" bIns="0" anchor="ctr"/>
-          <a:lstStyle/>
-          <a:p>
-            <a:pPr marL="0" indent="0" algn="l">
-              <a:buNone/>
-            </a:pPr>
-            <a:r>
-              <a:rPr lang="ru-RU" sz="1300" i="0">
-                <a:solidFill>
-                  <a:srgbClr val="595959"/>
-                </a:solidFill>
-                <a:latin typeface="Arial" panose="020B0604020202020204" pitchFamily="34" charset="0"/>
-                <a:cs typeface="Arial"/>
-              </a:rPr>
-              <a:t>Источник: </a:t>
-            </a:r>
-            <a:r>
-              <a:rPr lang="en-US" sz="1300" i="0">
-                <a:solidFill>
-                  <a:srgbClr val="595959"/>
-                </a:solidFill>
-                <a:latin typeface="Arial" panose="020B0604020202020204" pitchFamily="34" charset="0"/>
-                <a:cs typeface="Arial"/>
-              </a:rPr>
-              <a:t>reports/evaluation/metrics.csv; </a:t>
-            </a:r>
-            <a:r>
-              <a:rPr lang="ru-RU" sz="1300" i="0">
-                <a:solidFill>
-                  <a:srgbClr val="595959"/>
-                </a:solidFill>
-                <a:latin typeface="Arial" panose="020B0604020202020204" pitchFamily="34" charset="0"/>
-                <a:cs typeface="Arial"/>
-              </a:rPr>
-              <a:t>РПЗ, заключение</a:t>
-            </a:r>
-            <a:endParaRPr sz="1300" i="0">
-              <a:solidFill>
-                <a:srgbClr val="595959"/>
-              </a:solidFill>
-              <a:latin typeface="Arial" panose="020B0604020202020204" pitchFamily="34" charset="0"/>
-              <a:cs typeface="Arial"/>
-            </a:endParaRPr>
-          </a:p>
-        </p:txBody>
-      </p:sp>
-      <p:sp>
-        <p:nvSpPr>
           <p:cNvPr id="4" name="Номер слайда 3">
             <a:extLst>
               <a:ext uri="{FF2B5EF4-FFF2-40B4-BE49-F238E27FC236}">
@@ -15256,49 +14958,6 @@
             <a:endParaRPr sz="1700" i="0">
               <a:solidFill>
                 <a:srgbClr val="262626"/>
-              </a:solidFill>
-              <a:latin typeface="Arial" panose="020B0604020202020204" pitchFamily="34" charset="0"/>
-              <a:cs typeface="Arial"/>
-            </a:endParaRPr>
-          </a:p>
-        </p:txBody>
-      </p:sp>
-      <p:sp>
-        <p:nvSpPr>
-          <p:cNvPr id="88" name="Источник"/>
-          <p:cNvSpPr txBox="1"/>
-          <p:nvPr/>
-        </p:nvSpPr>
-        <p:spPr>
-          <a:xfrm>
-            <a:off x="960120" y="6336792"/>
-            <a:ext cx="10808208" cy="365760"/>
-          </a:xfrm>
-          <a:prstGeom prst="rect">
-            <a:avLst/>
-          </a:prstGeom>
-          <a:noFill/>
-        </p:spPr>
-        <p:txBody>
-          <a:bodyPr wrap="square" lIns="0" tIns="0" rIns="0" bIns="0" anchor="ctr"/>
-          <a:lstStyle/>
-          <a:p>
-            <a:pPr marL="0" indent="0" algn="l">
-              <a:buNone/>
-            </a:pPr>
-            <a:r>
-              <a:rPr lang="ru-RU" i="0">
-                <a:solidFill>
-                  <a:srgbClr val="595959"/>
-                </a:solidFill>
-                <a:latin typeface="Arial" panose="020B0604020202020204" pitchFamily="34" charset="0"/>
-                <a:cs typeface="Arial"/>
-              </a:rPr>
-              <a:t>Источник: РПЗ, введение</a:t>
-            </a:r>
-            <a:endParaRPr i="0">
-              <a:solidFill>
-                <a:srgbClr val="595959"/>
               </a:solidFill>
               <a:latin typeface="Arial" panose="020B0604020202020204" pitchFamily="34" charset="0"/>
               <a:cs typeface="Arial"/>
@@ -16697,49 +16356,6 @@
       </p:sp>
       <p:sp>
         <p:nvSpPr>
-          <p:cNvPr id="87" name="Источник"/>
-          <p:cNvSpPr txBox="1"/>
-          <p:nvPr/>
-        </p:nvSpPr>
-        <p:spPr>
-          <a:xfrm>
-            <a:off x="960120" y="6336792"/>
-            <a:ext cx="10808208" cy="365760"/>
-          </a:xfrm>
-          <a:prstGeom prst="rect">
-            <a:avLst/>
-          </a:prstGeom>
-          <a:noFill/>
-        </p:spPr>
-        <p:txBody>
-          <a:bodyPr wrap="square" lIns="0" tIns="0" rIns="0" bIns="0" anchor="ctr"/>
-          <a:lstStyle/>
-          <a:p>
-            <a:pPr marL="0" indent="0" algn="l">
-              <a:buNone/>
-            </a:pPr>
-            <a:r>
-              <a:rPr lang="ru-RU" sz="1300" i="0">
-                <a:solidFill>
-                  <a:srgbClr val="595959"/>
-                </a:solidFill>
-                <a:latin typeface="Arial" panose="020B0604020202020204" pitchFamily="34" charset="0"/>
-                <a:cs typeface="Arial"/>
-              </a:rPr>
-              <a:t>Источник: РПЗ, раздел 1.1 и таблица исходных данных; словарь данных репозитория</a:t>
-            </a:r>
-            <a:endParaRPr sz="1300" i="0">
-              <a:solidFill>
-                <a:srgbClr val="595959"/>
-              </a:solidFill>
-              <a:latin typeface="Arial" panose="020B0604020202020204" pitchFamily="34" charset="0"/>
-              <a:cs typeface="Arial"/>
-            </a:endParaRPr>
-          </a:p>
-        </p:txBody>
-      </p:sp>
-      <p:sp>
-        <p:nvSpPr>
           <p:cNvPr id="4" name="Номер слайда 3">
             <a:extLst>
               <a:ext uri="{FF2B5EF4-FFF2-40B4-BE49-F238E27FC236}">
@@ -17175,49 +16791,6 @@
       </p:grpSp>
       <p:sp>
         <p:nvSpPr>
-          <p:cNvPr id="76" name="Источник"/>
-          <p:cNvSpPr txBox="1"/>
-          <p:nvPr/>
-        </p:nvSpPr>
-        <p:spPr>
-          <a:xfrm>
-            <a:off x="960120" y="6336792"/>
-            <a:ext cx="10808208" cy="365760"/>
-          </a:xfrm>
-          <a:prstGeom prst="rect">
-            <a:avLst/>
-          </a:prstGeom>
-          <a:noFill/>
-        </p:spPr>
-        <p:txBody>
-          <a:bodyPr wrap="square" lIns="0" tIns="0" rIns="0" bIns="0" anchor="ctr"/>
-          <a:lstStyle/>
-          <a:p>
-            <a:pPr marL="0" indent="0" algn="l">
-              <a:buNone/>
-            </a:pPr>
-            <a:r>
-              <a:rPr lang="ru-RU" sz="1300" i="0">
-                <a:solidFill>
-                  <a:srgbClr val="595959"/>
-                </a:solidFill>
-                <a:latin typeface="Arial" panose="020B0604020202020204" pitchFamily="34" charset="0"/>
-                <a:cs typeface="Arial"/>
-              </a:rPr>
-              <a:t>Источник: РПЗ, разделы 1.2 и 2.1–2.6</a:t>
-            </a:r>
-            <a:endParaRPr sz="1300" i="0">
-              <a:solidFill>
-                <a:srgbClr val="595959"/>
-              </a:solidFill>
-              <a:latin typeface="Arial" panose="020B0604020202020204" pitchFamily="34" charset="0"/>
-              <a:cs typeface="Arial"/>
-            </a:endParaRPr>
-          </a:p>
-        </p:txBody>
-      </p:sp>
-      <p:sp>
-        <p:nvSpPr>
           <p:cNvPr id="5" name="Номер слайда 3">
             <a:extLst>
               <a:ext uri="{FF2B5EF4-FFF2-40B4-BE49-F238E27FC236}">
@@ -17255,81 +16828,6 @@
             <a:endParaRPr lang="ru-RU" dirty="0">
               <a:cs typeface="Arial"/>
             </a:endParaRPr>
-          </a:p>
-        </p:txBody>
-      </p:sp>
-      <p:sp>
-        <p:nvSpPr>
-          <p:cNvPr id="7" name="Текст 6">
-            <a:extLst>
-              <a:ext uri="{FF2B5EF4-FFF2-40B4-BE49-F238E27FC236}">
-                <a16:creationId xmlns:a16="http://schemas.microsoft.com/office/drawing/2014/main" id="{C819DC7D-B729-474D-92A8-9E837866C3EF}"/>
-              </a:ext>
-            </a:extLst>
-          </p:cNvPr>
-          <p:cNvSpPr>
-            <a:spLocks noGrp="1"/>
-          </p:cNvSpPr>
-          <p:nvPr>
-            <p:ph type="body" idx="14"/>
-          </p:nvPr>
-        </p:nvSpPr>
-        <p:spPr/>
-        <p:txBody>
-          <a:bodyPr/>
-          <a:lstStyle/>
-          <a:p>
-            <a:endParaRPr lang="ru-RU"/>
-          </a:p>
-        </p:txBody>
-      </p:sp>
-      <p:sp>
-        <p:nvSpPr>
-          <p:cNvPr id="9" name="Текст 8">
-            <a:extLst>
-              <a:ext uri="{FF2B5EF4-FFF2-40B4-BE49-F238E27FC236}">
-                <a16:creationId xmlns:a16="http://schemas.microsoft.com/office/drawing/2014/main" id="{7ED6C69E-38D1-4DED-9DAC-27FB7BBABA46}"/>
-              </a:ext>
-            </a:extLst>
-          </p:cNvPr>
-          <p:cNvSpPr>
-            <a:spLocks noGrp="1"/>
-          </p:cNvSpPr>
-          <p:nvPr>
-            <p:ph type="body" idx="2"/>
-          </p:nvPr>
-        </p:nvSpPr>
-        <p:spPr/>
-        <p:txBody>
-          <a:bodyPr/>
-          <a:lstStyle/>
-          <a:p>
-            <a:endParaRPr lang="ru-RU"/>
-          </a:p>
-        </p:txBody>
-      </p:sp>
-      <p:sp>
-        <p:nvSpPr>
-          <p:cNvPr id="11" name="Текст 10">
-            <a:extLst>
-              <a:ext uri="{FF2B5EF4-FFF2-40B4-BE49-F238E27FC236}">
-                <a16:creationId xmlns:a16="http://schemas.microsoft.com/office/drawing/2014/main" id="{1C545EA9-F8A6-44B3-B6BB-7EAE56AE6AAB}"/>
-              </a:ext>
-            </a:extLst>
-          </p:cNvPr>
-          <p:cNvSpPr>
-            <a:spLocks noGrp="1"/>
-          </p:cNvSpPr>
-          <p:nvPr>
-            <p:ph type="body" idx="13"/>
-          </p:nvPr>
-        </p:nvSpPr>
-        <p:spPr/>
-        <p:txBody>
-          <a:bodyPr/>
-          <a:lstStyle/>
-          <a:p>
-            <a:endParaRPr lang="ru-RU"/>
           </a:p>
         </p:txBody>
       </p:sp>
@@ -18332,49 +17830,6 @@
           </p:txBody>
         </p:sp>
       </p:grpSp>
-      <p:sp>
-        <p:nvSpPr>
-          <p:cNvPr id="83" name="Источник"/>
-          <p:cNvSpPr txBox="1"/>
-          <p:nvPr/>
-        </p:nvSpPr>
-        <p:spPr>
-          <a:xfrm>
-            <a:off x="960120" y="6336792"/>
-            <a:ext cx="10808208" cy="365760"/>
-          </a:xfrm>
-          <a:prstGeom prst="rect">
-            <a:avLst/>
-          </a:prstGeom>
-          <a:noFill/>
-        </p:spPr>
-        <p:txBody>
-          <a:bodyPr wrap="square" lIns="0" tIns="0" rIns="0" bIns="0" anchor="ctr"/>
-          <a:lstStyle/>
-          <a:p>
-            <a:pPr marL="0" indent="0" algn="l">
-              <a:buNone/>
-            </a:pPr>
-            <a:r>
-              <a:rPr lang="ru-RU" sz="1300" i="0">
-                <a:solidFill>
-                  <a:srgbClr val="595959"/>
-                </a:solidFill>
-                <a:latin typeface="Arial" panose="020B0604020202020204" pitchFamily="34" charset="0"/>
-                <a:cs typeface="Arial"/>
-              </a:rPr>
-              <a:t>Источник: РПЗ, разделы 1.1, 1.2 и 2.1</a:t>
-            </a:r>
-            <a:endParaRPr sz="1300" i="0">
-              <a:solidFill>
-                <a:srgbClr val="595959"/>
-              </a:solidFill>
-              <a:latin typeface="Arial" panose="020B0604020202020204" pitchFamily="34" charset="0"/>
-              <a:cs typeface="Arial"/>
-            </a:endParaRPr>
-          </a:p>
-        </p:txBody>
-      </p:sp>
       <p:sp>
         <p:nvSpPr>
           <p:cNvPr id="4" name="Номер слайда 3">
@@ -19461,49 +18916,6 @@
       </p:sp>
       <p:sp>
         <p:nvSpPr>
-          <p:cNvPr id="82" name="Источник"/>
-          <p:cNvSpPr txBox="1"/>
-          <p:nvPr/>
-        </p:nvSpPr>
-        <p:spPr>
-          <a:xfrm>
-            <a:off x="960120" y="6336792"/>
-            <a:ext cx="10808208" cy="365760"/>
-          </a:xfrm>
-          <a:prstGeom prst="rect">
-            <a:avLst/>
-          </a:prstGeom>
-          <a:noFill/>
-        </p:spPr>
-        <p:txBody>
-          <a:bodyPr wrap="square" lIns="0" tIns="0" rIns="0" bIns="0" anchor="ctr"/>
-          <a:lstStyle/>
-          <a:p>
-            <a:pPr marL="0" indent="0" algn="l">
-              <a:buNone/>
-            </a:pPr>
-            <a:r>
-              <a:rPr lang="ru-RU" sz="1300" i="0">
-                <a:solidFill>
-                  <a:srgbClr val="595959"/>
-                </a:solidFill>
-                <a:latin typeface="Arial" panose="020B0604020202020204" pitchFamily="34" charset="0"/>
-                <a:cs typeface="Arial"/>
-              </a:rPr>
-              <a:t>Источник: РПЗ, раздел разведочного анализа и рисунок с распределениями</a:t>
-            </a:r>
-            <a:endParaRPr sz="1300" i="0">
-              <a:solidFill>
-                <a:srgbClr val="595959"/>
-              </a:solidFill>
-              <a:latin typeface="Arial" panose="020B0604020202020204" pitchFamily="34" charset="0"/>
-              <a:cs typeface="Arial"/>
-            </a:endParaRPr>
-          </a:p>
-        </p:txBody>
-      </p:sp>
-      <p:sp>
-        <p:nvSpPr>
           <p:cNvPr id="4" name="Номер слайда 3">
             <a:extLst>
               <a:ext uri="{FF2B5EF4-FFF2-40B4-BE49-F238E27FC236}">
@@ -20599,59 +20011,6 @@
       </p:sp>
       <p:sp>
         <p:nvSpPr>
-          <p:cNvPr id="90" name="Источник"/>
-          <p:cNvSpPr txBox="1"/>
-          <p:nvPr/>
-        </p:nvSpPr>
-        <p:spPr>
-          <a:xfrm>
-            <a:off x="960120" y="6336792"/>
-            <a:ext cx="10808208" cy="365760"/>
-          </a:xfrm>
-          <a:prstGeom prst="rect">
-            <a:avLst/>
-          </a:prstGeom>
-          <a:noFill/>
-        </p:spPr>
-        <p:txBody>
-          <a:bodyPr wrap="square" lIns="0" tIns="0" rIns="0" bIns="0" anchor="ctr"/>
-          <a:lstStyle/>
-          <a:p>
-            <a:pPr marL="0" indent="0" algn="l">
-              <a:buNone/>
-            </a:pPr>
-            <a:r>
-              <a:rPr lang="ru-RU" sz="1300" i="0">
-                <a:solidFill>
-                  <a:srgbClr val="595959"/>
-                </a:solidFill>
-                <a:latin typeface="Arial" panose="020B0604020202020204" pitchFamily="34" charset="0"/>
-                <a:cs typeface="Arial"/>
-              </a:rPr>
-              <a:t>Источник: РПЗ, раздел предобработки; </a:t>
-            </a:r>
-            <a:r>
-              <a:rPr lang="en-US" sz="1300" i="0">
-                <a:solidFill>
-                  <a:srgbClr val="595959"/>
-                </a:solidFill>
-                <a:latin typeface="Arial" panose="020B0604020202020204" pitchFamily="34" charset="0"/>
-                <a:cs typeface="Arial"/>
-              </a:rPr>
-              <a:t>reports/modeling/preprocessing_audit.json</a:t>
-            </a:r>
-            <a:endParaRPr sz="1300" i="0">
-              <a:solidFill>
-                <a:srgbClr val="595959"/>
-              </a:solidFill>
-              <a:latin typeface="Arial" panose="020B0604020202020204" pitchFamily="34" charset="0"/>
-              <a:cs typeface="Arial"/>
-            </a:endParaRPr>
-          </a:p>
-        </p:txBody>
-      </p:sp>
-      <p:sp>
-        <p:nvSpPr>
           <p:cNvPr id="4" name="Номер слайда 3">
             <a:extLst>
               <a:ext uri="{FF2B5EF4-FFF2-40B4-BE49-F238E27FC236}">
@@ -21085,49 +20444,6 @@
           </p:txBody>
         </p:sp>
       </p:grpSp>
-      <p:sp>
-        <p:nvSpPr>
-          <p:cNvPr id="79" name="Источник"/>
-          <p:cNvSpPr txBox="1"/>
-          <p:nvPr/>
-        </p:nvSpPr>
-        <p:spPr>
-          <a:xfrm>
-            <a:off x="960120" y="6336792"/>
-            <a:ext cx="10808208" cy="365760"/>
-          </a:xfrm>
-          <a:prstGeom prst="rect">
-            <a:avLst/>
-          </a:prstGeom>
-          <a:noFill/>
-        </p:spPr>
-        <p:txBody>
-          <a:bodyPr wrap="square" lIns="0" tIns="0" rIns="0" bIns="0" anchor="ctr"/>
-          <a:lstStyle/>
-          <a:p>
-            <a:pPr marL="0" indent="0" algn="l">
-              <a:buNone/>
-            </a:pPr>
-            <a:r>
-              <a:rPr lang="ru-RU" sz="1300" i="0">
-                <a:solidFill>
-                  <a:srgbClr val="595959"/>
-                </a:solidFill>
-                <a:latin typeface="Arial" panose="020B0604020202020204" pitchFamily="34" charset="0"/>
-                <a:cs typeface="Arial"/>
-              </a:rPr>
-              <a:t>Источник: РПЗ, разделы о методах и проверке моделей; reports/modeling/cv_summary.csv</a:t>
-            </a:r>
-            <a:endParaRPr sz="1300" i="0">
-              <a:solidFill>
-                <a:srgbClr val="595959"/>
-              </a:solidFill>
-              <a:latin typeface="Arial" panose="020B0604020202020204" pitchFamily="34" charset="0"/>
-              <a:cs typeface="Arial"/>
-            </a:endParaRPr>
-          </a:p>
-        </p:txBody>
-      </p:sp>
       <p:sp>
         <p:nvSpPr>
           <p:cNvPr id="4" name="Номер слайда 3">
@@ -23117,49 +22433,6 @@
       </p:sp>
       <p:sp>
         <p:nvSpPr>
-          <p:cNvPr id="78" name="Источник"/>
-          <p:cNvSpPr txBox="1"/>
-          <p:nvPr/>
-        </p:nvSpPr>
-        <p:spPr>
-          <a:xfrm>
-            <a:off x="960120" y="6336792"/>
-            <a:ext cx="10808208" cy="365760"/>
-          </a:xfrm>
-          <a:prstGeom prst="rect">
-            <a:avLst/>
-          </a:prstGeom>
-          <a:noFill/>
-        </p:spPr>
-        <p:txBody>
-          <a:bodyPr wrap="square" lIns="0" tIns="0" rIns="0" bIns="0" anchor="ctr"/>
-          <a:lstStyle/>
-          <a:p>
-            <a:pPr marL="0" indent="0" algn="l">
-              <a:buNone/>
-            </a:pPr>
-            <a:r>
-              <a:rPr lang="ru-RU" sz="1300" i="0">
-                <a:solidFill>
-                  <a:srgbClr val="595959"/>
-                </a:solidFill>
-                <a:latin typeface="Arial" panose="020B0604020202020204" pitchFamily="34" charset="0"/>
-                <a:cs typeface="Arial"/>
-              </a:rPr>
-              <a:t>Источник: РПЗ, рисунок с фактическими и прогнозными значениями; reports/evaluation/metrics.csv</a:t>
-            </a:r>
-            <a:endParaRPr sz="1300" i="0">
-              <a:solidFill>
-                <a:srgbClr val="595959"/>
-              </a:solidFill>
-              <a:latin typeface="Arial" panose="020B0604020202020204" pitchFamily="34" charset="0"/>
-              <a:cs typeface="Arial"/>
-            </a:endParaRPr>
-          </a:p>
-        </p:txBody>
-      </p:sp>
-      <p:sp>
-        <p:nvSpPr>
           <p:cNvPr id="4" name="Номер слайда 3">
             <a:extLst>
               <a:ext uri="{FF2B5EF4-FFF2-40B4-BE49-F238E27FC236}">

</xml_diff>